<commit_message>
OutSystems: figuren ook in reader + echt ingebed in downloads
Twee gaten gedicht die na publicatie aan het licht kwamen:
- Alle 40 figuren stonden alleen in de slidedeck-tab, nooit in de
  reader (de brontekst had er geen [FIGUUR]-markers voor). Elk figuur
  op de inhoudelijk juiste plek in de bijbehorende reader.md ingevoegd
  (deel 26/29 bewust overgeslagen, geen figuren in die delen).
- De .docx/.pptx-downloads bevatten tot nu toe letterlijk de tekst
  "[FIGUUR x-y]" i.p.v. de afbeelding. Alle 40 SVG's gerasterized naar
  PNG (via headless Chromium, geen SVG-rasterizer op deze machine) en
  ingebed in reader.docx en slidedeck.pptx — inclusief een fix voor
  figuren die in een TABLE- of STATEMENT-slide staan (werden voorheen
  stilzwijgend overgeslagen in de pptx-builder).

Alle 30 delen (HTML, docx, pptx) opnieuw gegenereerd. 90 docx + 30
pptx gecontroleerd op corruptie (0 gevonden), 0 resterende
placeholders.
</commit_message>
<xml_diff>
--- a/outsystems/niveau-1/deel-01/slidedeck.pptx
+++ b/outsystems/niveau-1/deel-01/slidedeck.pptx
@@ -3408,8 +3408,8 @@
         </p:nvSpPr>
         <p:spPr>
           <a:xfrm>
-            <a:off x="640080" y="457200"/>
-            <a:ext cx="10881360" cy="731520"/>
+            <a:off x="640080" y="365760"/>
+            <a:ext cx="10881360" cy="640080"/>
           </a:xfrm>
           <a:prstGeom prst="rect">
             <a:avLst/>
@@ -3424,7 +3424,7 @@
           <a:p>
             <a:pPr algn="l"/>
             <a:r>
-              <a:rPr sz="2600" b="1">
+              <a:rPr sz="2400" b="1">
                 <a:solidFill>
                   <a:srgbClr val="14213D"/>
                 </a:solidFill>
@@ -3444,8 +3444,8 @@
           <p:nvPr/>
         </p:nvGraphicFramePr>
         <p:xfrm>
-          <a:off x="640080" y="1371600"/>
-          <a:ext cx="10881360" cy="2743200"/>
+          <a:off x="640080" y="1097280"/>
+          <a:ext cx="10881360" cy="2286000"/>
         </p:xfrm>
         <a:graphic>
           <a:graphicData uri="http://schemas.openxmlformats.org/drawingml/2006/table">
@@ -3458,7 +3458,7 @@
                 <a:gridCol w="3627120"/>
                 <a:gridCol w="3627120"/>
               </a:tblGrid>
-              <a:tr h="548640">
+              <a:tr h="457200">
                 <a:tc>
                   <a:txBody>
                     <a:bodyPr/>
@@ -3473,7 +3473,7 @@
                     <a:lstStyle/>
                     <a:p>
                       <a:r>
-                        <a:rPr sz="1600" b="1"/>
+                        <a:rPr sz="1400" b="1"/>
                         <a:t>OutSystems 11</a:t>
                       </a:r>
                     </a:p>
@@ -3486,7 +3486,7 @@
                     <a:lstStyle/>
                     <a:p>
                       <a:r>
-                        <a:rPr sz="1600" b="1"/>
+                        <a:rPr sz="1400" b="1"/>
                         <a:t>OutSystems Developer Cloud</a:t>
                       </a:r>
                     </a:p>
@@ -3494,14 +3494,14 @@
                   <a:tcPr/>
                 </a:tc>
               </a:tr>
-              <a:tr h="548640">
+              <a:tr h="457200">
                 <a:tc>
                   <a:txBody>
                     <a:bodyPr/>
                     <a:lstStyle/>
                     <a:p>
                       <a:r>
-                        <a:rPr sz="1600"/>
+                        <a:rPr sz="1400"/>
                         <a:t>Ontwikkelomgeving</a:t>
                       </a:r>
                     </a:p>
@@ -3514,7 +3514,7 @@
                     <a:lstStyle/>
                     <a:p>
                       <a:r>
-                        <a:rPr sz="1600"/>
+                        <a:rPr sz="1400"/>
                         <a:t>Service Studio</a:t>
                       </a:r>
                     </a:p>
@@ -3527,7 +3527,7 @@
                     <a:lstStyle/>
                     <a:p>
                       <a:r>
-                        <a:rPr sz="1600"/>
+                        <a:rPr sz="1400"/>
                         <a:t>ODC Studio</a:t>
                       </a:r>
                     </a:p>
@@ -3535,14 +3535,14 @@
                   <a:tcPr/>
                 </a:tc>
               </a:tr>
-              <a:tr h="548640">
+              <a:tr h="457200">
                 <a:tc>
                   <a:txBody>
                     <a:bodyPr/>
                     <a:lstStyle/>
                     <a:p>
                       <a:r>
-                        <a:rPr sz="1600"/>
+                        <a:rPr sz="1400"/>
                         <a:t>Lifecycle-beheer</a:t>
                       </a:r>
                     </a:p>
@@ -3555,7 +3555,7 @@
                     <a:lstStyle/>
                     <a:p>
                       <a:r>
-                        <a:rPr sz="1600"/>
+                        <a:rPr sz="1400"/>
                         <a:t>LifeTime</a:t>
                       </a:r>
                     </a:p>
@@ -3568,7 +3568,7 @@
                     <a:lstStyle/>
                     <a:p>
                       <a:r>
-                        <a:rPr sz="1600"/>
+                        <a:rPr sz="1400"/>
                         <a:t>ODC Portal</a:t>
                       </a:r>
                     </a:p>
@@ -3576,14 +3576,14 @@
                   <a:tcPr/>
                 </a:tc>
               </a:tr>
-              <a:tr h="548640">
+              <a:tr h="457200">
                 <a:tc>
                   <a:txBody>
                     <a:bodyPr/>
                     <a:lstStyle/>
                     <a:p>
                       <a:r>
-                        <a:rPr sz="1600"/>
+                        <a:rPr sz="1400"/>
                         <a:t>Deployment</a:t>
                       </a:r>
                     </a:p>
@@ -3596,7 +3596,7 @@
                     <a:lstStyle/>
                     <a:p>
                       <a:r>
-                        <a:rPr sz="1600"/>
+                        <a:rPr sz="1400"/>
                         <a:t>Publish naar Environment</a:t>
                       </a:r>
                     </a:p>
@@ -3609,7 +3609,7 @@
                     <a:lstStyle/>
                     <a:p>
                       <a:r>
-                        <a:rPr sz="1600"/>
+                        <a:rPr sz="1400"/>
                         <a:t>1-Click Publish</a:t>
                       </a:r>
                     </a:p>
@@ -3617,14 +3617,14 @@
                   <a:tcPr/>
                 </a:tc>
               </a:tr>
-              <a:tr h="548640">
+              <a:tr h="457200">
                 <a:tc>
                   <a:txBody>
                     <a:bodyPr/>
                     <a:lstStyle/>
                     <a:p>
                       <a:r>
-                        <a:rPr sz="1600"/>
+                        <a:rPr sz="1400"/>
                         <a:t>Bij Meridiaan</a:t>
                       </a:r>
                     </a:p>
@@ -3637,7 +3637,7 @@
                     <a:lstStyle/>
                     <a:p>
                       <a:r>
-                        <a:rPr sz="1600"/>
+                        <a:rPr sz="1400"/>
                         <a:t>Zes jaar productie, 14 satellieten</a:t>
                       </a:r>
                     </a:p>
@@ -3650,7 +3650,7 @@
                     <a:lstStyle/>
                     <a:p>
                       <a:r>
-                        <a:rPr sz="1600"/>
+                        <a:rPr sz="1400"/>
                         <a:t>Net afgesloten, nieuwbouw</a:t>
                       </a:r>
                     </a:p>
@@ -3662,6 +3662,30 @@
           </a:graphicData>
         </a:graphic>
       </p:graphicFrame>
+      <p:pic>
+        <p:nvPicPr>
+          <p:cNvPr id="4" name="Picture 3" descr="figuur-1-2.png"/>
+          <p:cNvPicPr>
+            <a:picLocks noChangeAspect="1"/>
+          </p:cNvPicPr>
+          <p:nvPr/>
+        </p:nvPicPr>
+        <p:blipFill>
+          <a:blip r:embed="rId2"/>
+          <a:stretch>
+            <a:fillRect/>
+          </a:stretch>
+        </p:blipFill>
+        <p:spPr>
+          <a:xfrm>
+            <a:off x="3147060" y="3657600"/>
+            <a:ext cx="5867399" cy="3017520"/>
+          </a:xfrm>
+          <a:prstGeom prst="rect">
+            <a:avLst/>
+          </a:prstGeom>
+        </p:spPr>
+      </p:pic>
     </p:spTree>
   </p:cSld>
   <p:clrMapOvr>
@@ -3889,8 +3913,8 @@
         </p:nvSpPr>
         <p:spPr>
           <a:xfrm>
-            <a:off x="640080" y="548640"/>
-            <a:ext cx="10881360" cy="914400"/>
+            <a:off x="640080" y="457200"/>
+            <a:ext cx="10881360" cy="822960"/>
           </a:xfrm>
           <a:prstGeom prst="rect">
             <a:avLst/>
@@ -4143,8 +4167,8 @@
         </p:nvSpPr>
         <p:spPr>
           <a:xfrm>
-            <a:off x="640080" y="548640"/>
-            <a:ext cx="10881360" cy="914400"/>
+            <a:off x="640080" y="457200"/>
+            <a:ext cx="10881360" cy="822960"/>
           </a:xfrm>
           <a:prstGeom prst="rect">
             <a:avLst/>
@@ -4178,8 +4202,8 @@
         </p:nvSpPr>
         <p:spPr>
           <a:xfrm>
-            <a:off x="822960" y="1737360"/>
-            <a:ext cx="10515600" cy="4114800"/>
+            <a:off x="640080" y="1463040"/>
+            <a:ext cx="5029200" cy="4937760"/>
           </a:xfrm>
           <a:prstGeom prst="rect">
             <a:avLst/>
@@ -4194,7 +4218,7 @@
           <a:p>
             <a:pPr algn="l"/>
             <a:r>
-              <a:rPr sz="2000" b="0">
+              <a:rPr sz="1700" b="0">
                 <a:solidFill>
                   <a:srgbClr val="14213D"/>
                 </a:solidFill>
@@ -4206,7 +4230,7 @@
           <a:p>
             <a:pPr algn="l"/>
             <a:r>
-              <a:rPr sz="2000" b="0">
+              <a:rPr sz="1700" b="0">
                 <a:solidFill>
                   <a:srgbClr val="14213D"/>
                 </a:solidFill>
@@ -4218,7 +4242,7 @@
           <a:p>
             <a:pPr algn="l"/>
             <a:r>
-              <a:rPr sz="2000" b="0">
+              <a:rPr sz="1700" b="0">
                 <a:solidFill>
                   <a:srgbClr val="14213D"/>
                 </a:solidFill>
@@ -4230,7 +4254,7 @@
           <a:p>
             <a:pPr algn="l"/>
             <a:r>
-              <a:rPr sz="2000" b="0">
+              <a:rPr sz="1700" b="0">
                 <a:solidFill>
                   <a:srgbClr val="14213D"/>
                 </a:solidFill>
@@ -4241,41 +4265,30 @@
           </a:p>
         </p:txBody>
       </p:sp>
-      <p:sp>
-        <p:nvSpPr>
-          <p:cNvPr id="4" name="TextBox 3"/>
-          <p:cNvSpPr txBox="1"/>
+      <p:pic>
+        <p:nvPicPr>
+          <p:cNvPr id="4" name="Picture 3" descr="figuur-1-1.png"/>
+          <p:cNvPicPr>
+            <a:picLocks noChangeAspect="1"/>
+          </p:cNvPicPr>
           <p:nvPr/>
-        </p:nvSpPr>
+        </p:nvPicPr>
+        <p:blipFill>
+          <a:blip r:embed="rId2"/>
+          <a:stretch>
+            <a:fillRect/>
+          </a:stretch>
+        </p:blipFill>
         <p:spPr>
           <a:xfrm>
-            <a:off x="822960" y="5943600"/>
-            <a:ext cx="10515600" cy="731520"/>
+            <a:off x="5852160" y="2519825"/>
+            <a:ext cx="5669280" cy="2915629"/>
           </a:xfrm>
           <a:prstGeom prst="rect">
             <a:avLst/>
           </a:prstGeom>
-          <a:noFill/>
         </p:spPr>
-        <p:txBody>
-          <a:bodyPr wrap="square">
-            <a:spAutoFit/>
-          </a:bodyPr>
-          <a:lstStyle/>
-          <a:p>
-            <a:pPr algn="l"/>
-            <a:r>
-              <a:rPr sz="1300" b="0">
-                <a:solidFill>
-                  <a:srgbClr val="999999"/>
-                </a:solidFill>
-                <a:latin typeface="DM Sans"/>
-              </a:rPr>
-              <a:t>[FIGUUR 1-1: Meridiaan-landschap — Mutatieplatform, Mutatie-API, WGP + satellieten, positie van deze cursus]</a:t>
-            </a:r>
-          </a:p>
-        </p:txBody>
-      </p:sp>
+      </p:pic>
     </p:spTree>
   </p:cSld>
   <p:clrMapOvr>
@@ -4383,8 +4396,8 @@
         </p:nvSpPr>
         <p:spPr>
           <a:xfrm>
-            <a:off x="640080" y="548640"/>
-            <a:ext cx="10881360" cy="914400"/>
+            <a:off x="640080" y="457200"/>
+            <a:ext cx="10881360" cy="822960"/>
           </a:xfrm>
           <a:prstGeom prst="rect">
             <a:avLst/>
@@ -4515,8 +4528,8 @@
         </p:nvSpPr>
         <p:spPr>
           <a:xfrm>
-            <a:off x="640080" y="548640"/>
-            <a:ext cx="10881360" cy="914400"/>
+            <a:off x="640080" y="457200"/>
+            <a:ext cx="10881360" cy="822960"/>
           </a:xfrm>
           <a:prstGeom prst="rect">
             <a:avLst/>
@@ -4828,8 +4841,8 @@
         </p:nvSpPr>
         <p:spPr>
           <a:xfrm>
-            <a:off x="640080" y="548640"/>
-            <a:ext cx="10881360" cy="914400"/>
+            <a:off x="640080" y="457200"/>
+            <a:ext cx="10881360" cy="822960"/>
           </a:xfrm>
           <a:prstGeom prst="rect">
             <a:avLst/>

</xml_diff>